<commit_message>
Decks v5: add APTOS size-stratified result
Co-Authored-By: Claude Sonnet 5.5 <noreply@anthropic.com>
Claude-Session: https://claude.ai/code/session_01Mrmk7xtGXEASaZHBUGuSEF
</commit_message>
<xml_diff>
--- a/DR_Progress_v5.pptx
+++ b/DR_Progress_v5.pptx
@@ -22881,7 +22881,7 @@
                 </a:solidFill>
                 <a:latin typeface="Arial"/>
               </a:rPr>
-              <a:t>• Prepared, not yet run: APTOS size-stratified check</a:t>
+              <a:t>• APTOS size-stratified check (post-hoc): AUROC 0.984 to 0.989 within same-size groups, so size alone does not explain 0.99</a:t>
             </a:r>
           </a:p>
         </p:txBody>
@@ -22961,7 +22961,7 @@
                 </a:solidFill>
                 <a:latin typeface="Arial"/>
               </a:rPr>
-              <a:t>• Size-stratified and matched-subset checks for APTOS</a:t>
+              <a:t>• Matched-subset check for APTOS (other capture cues)</a:t>
             </a:r>
           </a:p>
           <a:p>
@@ -24535,7 +24535,7 @@
                 </a:solidFill>
                 <a:latin typeface="Arial"/>
               </a:rPr>
-              <a:t>Image size alone predicts APTOS early DR (AUROC 0.96): its 0.994 is not clean evidence of robustness.</a:t>
+              <a:t>Size alone predicts APTOS (0.96), but within same-size groups the models still score 0.984 to 0.989 (post-hoc). Other capture cues remain untested.</a:t>
             </a:r>
           </a:p>
         </p:txBody>
@@ -25115,7 +25115,7 @@
                 </a:solidFill>
                 <a:latin typeface="Arial"/>
               </a:rPr>
-              <a:t>1. Run the APTOS size-stratified check (saved predictions only)</a:t>
+              <a:t>1. Size check done: APTOS AUROC holds within same-size groups (0.984 to 0.989)</a:t>
             </a:r>
           </a:p>
           <a:p>

</xml_diff>